<commit_message>
Fix poster CSV reproduction and clarify growth-model methods
</commit_message>
<xml_diff>
--- a/CUPC_Poster_portrait_36x48.pptx
+++ b/CUPC_Poster_portrait_36x48.pptx
@@ -129,7 +129,7 @@
   <pc:docChgLst>
     <pc:chgData name="Nicole Jiang" userId="09ef0fc0f6f473b5" providerId="LiveId" clId="{EB8F4A53-0964-5BF1-90AD-931457E28E1A}"/>
     <pc:docChg chg="undo redo custSel addSld delSld modSld">
-      <pc:chgData name="Nicole Jiang" userId="09ef0fc0f6f473b5" providerId="LiveId" clId="{EB8F4A53-0964-5BF1-90AD-931457E28E1A}" dt="2026-10-13T17:35:40.898" v="2607" actId="2696"/>
+      <pc:chgData name="Nicole Jiang" userId="09ef0fc0f6f473b5" providerId="LiveId" clId="{EB8F4A53-0964-5BF1-90AD-931457E28E1A}" dt="2026-10-13T21:07:31.461" v="2663" actId="255"/>
       <pc:docMkLst>
         <pc:docMk/>
       </pc:docMkLst>
@@ -141,13 +141,13 @@
         </pc:sldMkLst>
       </pc:sldChg>
       <pc:sldChg chg="addSp delSp modSp mod">
-        <pc:chgData name="Nicole Jiang" userId="09ef0fc0f6f473b5" providerId="LiveId" clId="{EB8F4A53-0964-5BF1-90AD-931457E28E1A}" dt="2026-10-13T17:35:09.918" v="2597" actId="22"/>
+        <pc:chgData name="Nicole Jiang" userId="09ef0fc0f6f473b5" providerId="LiveId" clId="{EB8F4A53-0964-5BF1-90AD-931457E28E1A}" dt="2026-10-13T21:07:31.461" v="2663" actId="255"/>
         <pc:sldMkLst>
           <pc:docMk/>
           <pc:sldMk cId="868487171" sldId="260"/>
         </pc:sldMkLst>
         <pc:spChg chg="mod">
-          <ac:chgData name="Nicole Jiang" userId="09ef0fc0f6f473b5" providerId="LiveId" clId="{EB8F4A53-0964-5BF1-90AD-931457E28E1A}" dt="2026-10-13T04:31:23.380" v="2548" actId="14100"/>
+          <ac:chgData name="Nicole Jiang" userId="09ef0fc0f6f473b5" providerId="LiveId" clId="{EB8F4A53-0964-5BF1-90AD-931457E28E1A}" dt="2026-10-13T21:07:08.915" v="2657" actId="255"/>
           <ac:spMkLst>
             <pc:docMk/>
             <pc:sldMk cId="868487171" sldId="260"/>
@@ -195,7 +195,7 @@
           </ac:spMkLst>
         </pc:spChg>
         <pc:spChg chg="add mod">
-          <ac:chgData name="Nicole Jiang" userId="09ef0fc0f6f473b5" providerId="LiveId" clId="{EB8F4A53-0964-5BF1-90AD-931457E28E1A}" dt="2026-10-13T04:31:17.775" v="2547" actId="14100"/>
+          <ac:chgData name="Nicole Jiang" userId="09ef0fc0f6f473b5" providerId="LiveId" clId="{EB8F4A53-0964-5BF1-90AD-931457E28E1A}" dt="2026-10-13T21:07:24.355" v="2661" actId="255"/>
           <ac:spMkLst>
             <pc:docMk/>
             <pc:sldMk cId="868487171" sldId="260"/>
@@ -227,7 +227,7 @@
           </ac:spMkLst>
         </pc:spChg>
         <pc:spChg chg="mod">
-          <ac:chgData name="Nicole Jiang" userId="09ef0fc0f6f473b5" providerId="LiveId" clId="{EB8F4A53-0964-5BF1-90AD-931457E28E1A}" dt="2026-10-13T04:30:28.266" v="2534" actId="14100"/>
+          <ac:chgData name="Nicole Jiang" userId="09ef0fc0f6f473b5" providerId="LiveId" clId="{EB8F4A53-0964-5BF1-90AD-931457E28E1A}" dt="2026-10-13T21:07:12.551" v="2658" actId="255"/>
           <ac:spMkLst>
             <pc:docMk/>
             <pc:sldMk cId="868487171" sldId="260"/>
@@ -235,7 +235,7 @@
           </ac:spMkLst>
         </pc:spChg>
         <pc:spChg chg="mod">
-          <ac:chgData name="Nicole Jiang" userId="09ef0fc0f6f473b5" providerId="LiveId" clId="{EB8F4A53-0964-5BF1-90AD-931457E28E1A}" dt="2026-10-13T04:30:53.652" v="2541" actId="14100"/>
+          <ac:chgData name="Nicole Jiang" userId="09ef0fc0f6f473b5" providerId="LiveId" clId="{EB8F4A53-0964-5BF1-90AD-931457E28E1A}" dt="2026-10-13T21:02:41.287" v="2608" actId="14100"/>
           <ac:spMkLst>
             <pc:docMk/>
             <pc:sldMk cId="868487171" sldId="260"/>
@@ -243,7 +243,7 @@
           </ac:spMkLst>
         </pc:spChg>
         <pc:spChg chg="mod">
-          <ac:chgData name="Nicole Jiang" userId="09ef0fc0f6f473b5" providerId="LiveId" clId="{EB8F4A53-0964-5BF1-90AD-931457E28E1A}" dt="2026-10-13T04:30:27.674" v="2532" actId="1076"/>
+          <ac:chgData name="Nicole Jiang" userId="09ef0fc0f6f473b5" providerId="LiveId" clId="{EB8F4A53-0964-5BF1-90AD-931457E28E1A}" dt="2026-10-13T21:02:47.022" v="2609" actId="1076"/>
           <ac:spMkLst>
             <pc:docMk/>
             <pc:sldMk cId="868487171" sldId="260"/>
@@ -251,7 +251,7 @@
           </ac:spMkLst>
         </pc:spChg>
         <pc:spChg chg="mod">
-          <ac:chgData name="Nicole Jiang" userId="09ef0fc0f6f473b5" providerId="LiveId" clId="{EB8F4A53-0964-5BF1-90AD-931457E28E1A}" dt="2026-10-13T04:30:25.812" v="2529" actId="1076"/>
+          <ac:chgData name="Nicole Jiang" userId="09ef0fc0f6f473b5" providerId="LiveId" clId="{EB8F4A53-0964-5BF1-90AD-931457E28E1A}" dt="2026-10-13T21:07:15.797" v="2659" actId="255"/>
           <ac:spMkLst>
             <pc:docMk/>
             <pc:sldMk cId="868487171" sldId="260"/>
@@ -259,7 +259,7 @@
           </ac:spMkLst>
         </pc:spChg>
         <pc:spChg chg="mod">
-          <ac:chgData name="Nicole Jiang" userId="09ef0fc0f6f473b5" providerId="LiveId" clId="{EB8F4A53-0964-5BF1-90AD-931457E28E1A}" dt="2026-10-13T04:30:29.517" v="2537" actId="14100"/>
+          <ac:chgData name="Nicole Jiang" userId="09ef0fc0f6f473b5" providerId="LiveId" clId="{EB8F4A53-0964-5BF1-90AD-931457E28E1A}" dt="2026-10-13T21:03:18.931" v="2617" actId="14100"/>
           <ac:spMkLst>
             <pc:docMk/>
             <pc:sldMk cId="868487171" sldId="260"/>
@@ -275,7 +275,7 @@
           </ac:spMkLst>
         </pc:spChg>
         <pc:spChg chg="mod">
-          <ac:chgData name="Nicole Jiang" userId="09ef0fc0f6f473b5" providerId="LiveId" clId="{EB8F4A53-0964-5BF1-90AD-931457E28E1A}" dt="2026-10-13T04:31:14.790" v="2546" actId="14100"/>
+          <ac:chgData name="Nicole Jiang" userId="09ef0fc0f6f473b5" providerId="LiveId" clId="{EB8F4A53-0964-5BF1-90AD-931457E28E1A}" dt="2026-10-13T21:07:19.681" v="2660" actId="255"/>
           <ac:spMkLst>
             <pc:docMk/>
             <pc:sldMk cId="868487171" sldId="260"/>
@@ -299,7 +299,7 @@
           </ac:spMkLst>
         </pc:spChg>
         <pc:spChg chg="mod">
-          <ac:chgData name="Nicole Jiang" userId="09ef0fc0f6f473b5" providerId="LiveId" clId="{EB8F4A53-0964-5BF1-90AD-931457E28E1A}" dt="2026-10-13T04:33:31.799" v="2571" actId="1076"/>
+          <ac:chgData name="Nicole Jiang" userId="09ef0fc0f6f473b5" providerId="LiveId" clId="{EB8F4A53-0964-5BF1-90AD-931457E28E1A}" dt="2026-10-13T21:07:28.149" v="2662" actId="255"/>
           <ac:spMkLst>
             <pc:docMk/>
             <pc:sldMk cId="868487171" sldId="260"/>
@@ -323,7 +323,7 @@
           </ac:spMkLst>
         </pc:spChg>
         <pc:spChg chg="mod">
-          <ac:chgData name="Nicole Jiang" userId="09ef0fc0f6f473b5" providerId="LiveId" clId="{EB8F4A53-0964-5BF1-90AD-931457E28E1A}" dt="2026-10-13T17:26:01.614" v="2595" actId="1076"/>
+          <ac:chgData name="Nicole Jiang" userId="09ef0fc0f6f473b5" providerId="LiveId" clId="{EB8F4A53-0964-5BF1-90AD-931457E28E1A}" dt="2026-10-13T21:07:31.461" v="2663" actId="255"/>
           <ac:spMkLst>
             <pc:docMk/>
             <pc:sldMk cId="868487171" sldId="260"/>
@@ -347,7 +347,7 @@
           </ac:spMkLst>
         </pc:spChg>
         <pc:spChg chg="mod">
-          <ac:chgData name="Nicole Jiang" userId="09ef0fc0f6f473b5" providerId="LiveId" clId="{EB8F4A53-0964-5BF1-90AD-931457E28E1A}" dt="2026-10-13T04:35:01.208" v="2578" actId="1076"/>
+          <ac:chgData name="Nicole Jiang" userId="09ef0fc0f6f473b5" providerId="LiveId" clId="{EB8F4A53-0964-5BF1-90AD-931457E28E1A}" dt="2026-10-13T21:03:27.266" v="2618" actId="1076"/>
           <ac:spMkLst>
             <pc:docMk/>
             <pc:sldMk cId="868487171" sldId="260"/>
@@ -362,8 +362,16 @@
             <ac:spMk id="112" creationId="{00000000-0000-0000-0000-000000000000}"/>
           </ac:spMkLst>
         </pc:spChg>
+        <pc:spChg chg="mod">
+          <ac:chgData name="Nicole Jiang" userId="09ef0fc0f6f473b5" providerId="LiveId" clId="{EB8F4A53-0964-5BF1-90AD-931457E28E1A}" dt="2026-10-13T21:03:36.169" v="2620" actId="1076"/>
+          <ac:spMkLst>
+            <pc:docMk/>
+            <pc:sldMk cId="868487171" sldId="260"/>
+            <ac:spMk id="120" creationId="{3A05E1FE-512D-49F3-9C39-22D275F0EE18}"/>
+          </ac:spMkLst>
+        </pc:spChg>
         <pc:picChg chg="mod">
-          <ac:chgData name="Nicole Jiang" userId="09ef0fc0f6f473b5" providerId="LiveId" clId="{EB8F4A53-0964-5BF1-90AD-931457E28E1A}" dt="2026-10-13T04:35:03.777" v="2579" actId="1076"/>
+          <ac:chgData name="Nicole Jiang" userId="09ef0fc0f6f473b5" providerId="LiveId" clId="{EB8F4A53-0964-5BF1-90AD-931457E28E1A}" dt="2026-10-13T21:03:29.514" v="2619" actId="1076"/>
           <ac:picMkLst>
             <pc:docMk/>
             <pc:sldMk cId="868487171" sldId="260"/>
@@ -4812,7 +4820,7 @@
         </p:blipFill>
         <p:spPr>
           <a:xfrm>
-            <a:off x="914400" y="25648920"/>
+            <a:off x="1005840" y="26251523"/>
             <a:ext cx="15087600" cy="10515600"/>
           </a:xfrm>
           <a:prstGeom prst="rect">
@@ -5114,7 +5122,7 @@
         <p:spPr>
           <a:xfrm>
             <a:off x="1371600" y="6642638"/>
-            <a:ext cx="14173200" cy="2785378"/>
+            <a:ext cx="14173200" cy="2631490"/>
           </a:xfrm>
           <a:prstGeom prst="rect">
             <a:avLst/>
@@ -5131,13 +5139,13 @@
               <a:buNone/>
             </a:pPr>
             <a:r>
-              <a:rPr lang="en-CA" sz="3500" b="1" dirty="0">
+              <a:rPr lang="en-CA" sz="3300" b="1" dirty="0">
                 <a:latin typeface="Aptos"/>
               </a:rPr>
               <a:t>How did early black holes grow so big, so fast? </a:t>
             </a:r>
             <a:r>
-              <a:rPr lang="en-CA" sz="3500" b="0" dirty="0">
+              <a:rPr lang="en-CA" sz="3300" b="0" dirty="0">
                 <a:latin typeface="Aptos"/>
               </a:rPr>
               <a:t>The James Webb Space Telescope (JWST) has revealed massive black holes with little time to assemble. My research builds a standardized catalogue across studies, then tests objects against analytic growth models to identify the strongest constraints and how they depend on the assumptions.</a:t>
@@ -5160,7 +5168,7 @@
         <p:spPr>
           <a:xfrm>
             <a:off x="914400" y="5362478"/>
-            <a:ext cx="15087600" cy="4819475"/>
+            <a:ext cx="15087600" cy="4543185"/>
           </a:xfrm>
           <a:prstGeom prst="rect">
             <a:avLst/>
@@ -5213,7 +5221,7 @@
         </p:nvSpPr>
         <p:spPr>
           <a:xfrm>
-            <a:off x="914400" y="10770678"/>
+            <a:off x="914400" y="10359156"/>
             <a:ext cx="15087600" cy="960120"/>
           </a:xfrm>
           <a:prstGeom prst="rect">
@@ -5260,8 +5268,8 @@
           </a:p>
         </p:txBody>
       </p:sp>
-      <mc:AlternateContent xmlns:mc="http://schemas.openxmlformats.org/markup-compatibility/2006" xmlns:a14="http://schemas.microsoft.com/office/drawing/2010/main">
-        <mc:Choice Requires="a14">
+      <mc:AlternateContent xmlns:mc="http://schemas.openxmlformats.org/markup-compatibility/2006">
+        <mc:Choice xmlns:a14="http://schemas.microsoft.com/office/drawing/2010/main" Requires="a14">
           <p:sp>
             <p:nvSpPr>
               <p:cNvPr id="73" name="TextBox 72">
@@ -5276,8 +5284,8 @@
             </p:nvSpPr>
             <p:spPr>
               <a:xfrm>
-                <a:off x="1463040" y="11978640"/>
-                <a:ext cx="14173200" cy="12344400"/>
+                <a:off x="1463040" y="11772769"/>
+                <a:ext cx="14173200" cy="12984480"/>
               </a:xfrm>
               <a:prstGeom prst="rect">
                 <a:avLst/>
@@ -5297,16 +5305,16 @@
                   <a:buNone/>
                 </a:pPr>
                 <a:r>
-                  <a:rPr lang="en-CA" sz="3500" b="1" dirty="0">
+                  <a:rPr lang="en-CA" sz="3300" b="1" dirty="0">
                     <a:latin typeface="Aptos"/>
                   </a:rPr>
                   <a:t>Catalogue: </a:t>
                 </a:r>
                 <a:r>
-                  <a:rPr lang="en-CA" sz="3500" b="0" dirty="0">
+                  <a:rPr lang="en-CA" sz="3300" b="0" dirty="0">
                     <a:latin typeface="Aptos"/>
                   </a:rPr>
-                  <a:t>350 published measurements from 32 source families at z ≥ 4. Adopt one measurement per object and retain sources, methods, and alternatives. Primary: 220 objects with Balmer-line virial masses [1]; expanded: 234, including tentative candidates and GN-z11 [2].</a:t>
+                  <a:t>Compiled 350 published measurements from 32 source families at z ≥ 4. Adopted 1 measurement per object and retained sources, methods, and alternatives. Primary: 220 objects with Balmer-line virial masses [1]; expanded: 234, including tentative candidates and GN-z11 [2].</a:t>
                 </a:r>
               </a:p>
               <a:p>
@@ -5317,64 +5325,84 @@
                   <a:buNone/>
                 </a:pPr>
                 <a:r>
-                  <a:rPr lang="en-CA" sz="3500" b="1" dirty="0">
+                  <a:rPr lang="en-CA" sz="3300" b="1" dirty="0">
                     <a:latin typeface="Aptos"/>
                   </a:rPr>
                   <a:t>Reference model: </a:t>
                 </a:r>
                 <a:r>
-                  <a:rPr lang="en-CA" sz="3500" b="0" dirty="0">
+                  <a:rPr lang="en-CA" sz="3300" b="0" dirty="0">
                     <a:latin typeface="Aptos"/>
                   </a:rPr>
-                  <a:t>100 M⊙ seeds at z = 30, radiative efficiency </a:t>
-                </a:r>
-                <a:r>
-                  <a:rPr lang="en-CA" sz="3500" b="0" dirty="0" err="1">
+                  <a:t>Assumed 100 M⊙ seeds at z = 30, radiative efficiency </a:t>
+                </a:r>
+                <a:r>
+                  <a:rPr lang="en-CA" sz="3300" b="0" dirty="0" err="1">
                     <a:latin typeface="Aptos"/>
                   </a:rPr>
                   <a:t>ε</a:t>
                 </a:r>
                 <a:r>
-                  <a:rPr lang="en-CA" sz="3500" b="0" dirty="0">
+                  <a:rPr lang="en-CA" sz="3300" b="0" dirty="0">
                     <a:latin typeface="Aptos"/>
                   </a:rPr>
                   <a:t> = 0.1, no mergers (</a:t>
                 </a:r>
                 <a:r>
-                  <a:rPr lang="en-CA" sz="3500" b="0" dirty="0" err="1">
+                  <a:rPr lang="en-CA" sz="3300" b="0" dirty="0" err="1">
                     <a:latin typeface="Aptos"/>
                   </a:rPr>
                   <a:t>B</a:t>
                 </a:r>
                 <a:r>
-                  <a:rPr lang="en-CA" sz="2450" b="0" baseline="-25000" dirty="0" err="1">
+                  <a:rPr lang="en-CA" sz="3300" b="0" baseline="-25000" dirty="0" err="1">
                     <a:latin typeface="Aptos"/>
                   </a:rPr>
                   <a:t>merge</a:t>
                 </a:r>
                 <a:r>
-                  <a:rPr lang="en-CA" sz="3500" b="0" dirty="0">
+                  <a:rPr lang="en-CA" sz="3300" b="0" dirty="0">
                     <a:latin typeface="Aptos"/>
                   </a:rPr>
                   <a:t> = 1), and </a:t>
                 </a:r>
                 <a:r>
-                  <a:rPr lang="en-CA" sz="3500" b="0" dirty="0" err="1">
+                  <a:rPr lang="en-CA" sz="3300" b="0" dirty="0" err="1">
                     <a:latin typeface="Aptos"/>
                   </a:rPr>
                   <a:t>t</a:t>
                 </a:r>
                 <a:r>
-                  <a:rPr lang="en-CA" sz="2450" b="0" baseline="-25000" dirty="0" err="1">
+                  <a:rPr lang="en-CA" sz="3300" b="0" baseline="-25000" dirty="0" err="1">
                     <a:latin typeface="Aptos"/>
                   </a:rPr>
                   <a:t>Edd</a:t>
                 </a:r>
                 <a:r>
-                  <a:rPr lang="en-CA" sz="3500" b="0" dirty="0">
+                  <a:rPr lang="en-CA" sz="3300" b="0" dirty="0">
                     <a:latin typeface="Aptos"/>
                   </a:rPr>
                   <a:t> ≈ 0.45 Gyr [3].</a:t>
+                </a:r>
+              </a:p>
+              <a:p>
+                <a:pPr>
+                  <a:spcAft>
+                    <a:spcPts val="500"/>
+                  </a:spcAft>
+                  <a:buNone/>
+                </a:pPr>
+                <a:r>
+                  <a:rPr sz="3300" b="1" i="0" lang="en-CA">
+                    <a:latin typeface="Aptos"/>
+                  </a:rPr>
+                  <a:t>Model tests: </a:t>
+                </a:r>
+                <a:r>
+                  <a:rPr sz="3300" b="0" i="0" lang="en-CA">
+                    <a:latin typeface="Aptos"/>
+                  </a:rPr>
+                  <a:t>Calculated the average Eddington ratio required to reach each observed mass. Ranked these requirements and compared them with each model’s allowed average.</a:t>
                 </a:r>
               </a:p>
               <a:p>
@@ -5392,7 +5420,7 @@
                       <m:sSub>
                         <m:sSubPr>
                           <m:ctrlPr>
-                            <a:rPr lang="en-US" sz="3500" i="1">
+                            <a:rPr lang="en-US" sz="3300" i="1">
                               <a:latin typeface="Cambria Math" panose="02040503050406030204" pitchFamily="18" charset="0"/>
                             </a:rPr>
                           </m:ctrlPr>
@@ -5402,14 +5430,14 @@
                             <m:barPr>
                               <m:pos m:val="top"/>
                               <m:ctrlPr>
-                                <a:rPr lang="en-US" sz="3500" i="1">
+                                <a:rPr lang="en-US" sz="3300" i="1">
                                   <a:latin typeface="Cambria Math"/>
                                 </a:rPr>
                               </m:ctrlPr>
                             </m:barPr>
                             <m:e>
                               <m:r>
-                                <a:rPr lang="en-US" sz="3500" i="1">
+                                <a:rPr lang="en-US" sz="3300" i="1">
                                   <a:latin typeface="Cambria Math"/>
                                 </a:rPr>
                                 <m:t>𝑓</m:t>
@@ -5422,13 +5450,13 @@
                             <m:rPr>
                               <m:sty m:val="p"/>
                             </m:rPr>
-                            <a:rPr lang="en-US" sz="3500" i="0">
+                            <a:rPr lang="en-US" sz="3300" i="0">
                               <a:latin typeface="Cambria Math"/>
                             </a:rPr>
                             <m:t>Edd</m:t>
                           </m:r>
                           <m:r>
-                            <a:rPr lang="en-US" sz="3500" i="0">
+                            <a:rPr lang="en-US" sz="3300" i="0">
                               <a:latin typeface="Cambria Math"/>
                             </a:rPr>
                             <m:t>,</m:t>
@@ -5437,7 +5465,7 @@
                             <m:rPr>
                               <m:sty m:val="p"/>
                             </m:rPr>
-                            <a:rPr lang="en-US" sz="3500" i="0">
+                            <a:rPr lang="en-US" sz="3300" i="0">
                               <a:latin typeface="Cambria Math"/>
                             </a:rPr>
                             <m:t>req</m:t>
@@ -5445,7 +5473,7 @@
                         </m:sub>
                       </m:sSub>
                       <m:r>
-                        <a:rPr lang="en-US" sz="3500" i="1">
+                        <a:rPr lang="en-US" sz="3300" i="1">
                           <a:latin typeface="Cambria Math"/>
                         </a:rPr>
                         <m:t>=</m:t>
@@ -5453,7 +5481,7 @@
                       <m:func>
                         <m:funcPr>
                           <m:ctrlPr>
-                            <a:rPr lang="en-US" sz="3500" i="0">
+                            <a:rPr lang="en-US" sz="3300" i="0">
                               <a:latin typeface="Cambria Math"/>
                             </a:rPr>
                           </m:ctrlPr>
@@ -5463,7 +5491,7 @@
                             <m:rPr>
                               <m:sty m:val="p"/>
                             </m:rPr>
-                            <a:rPr lang="en-US" sz="3500" i="0">
+                            <a:rPr lang="en-US" sz="3300" i="0">
                               <a:latin typeface="Cambria Math"/>
                             </a:rPr>
                             <m:t>max</m:t>
@@ -5475,14 +5503,14 @@
                               <m:begChr m:val="["/>
                               <m:endChr m:val="]"/>
                               <m:ctrlPr>
-                                <a:rPr lang="en-US" sz="3500" i="1">
+                                <a:rPr lang="en-US" sz="3300" i="1">
                                   <a:latin typeface="Cambria Math"/>
                                 </a:rPr>
                               </m:ctrlPr>
                             </m:dPr>
                             <m:e>
                               <m:r>
-                                <a:rPr lang="en-US" sz="3500" i="1">
+                                <a:rPr lang="en-US" sz="3300" i="1">
                                   <a:latin typeface="Cambria Math"/>
                                 </a:rPr>
                                 <m:t>0,</m:t>
@@ -5490,14 +5518,14 @@
                               <m:f>
                                 <m:fPr>
                                   <m:ctrlPr>
-                                    <a:rPr lang="en-US" sz="3500" i="1">
+                                    <a:rPr lang="en-US" sz="3300" i="1">
                                       <a:latin typeface="Cambria Math"/>
                                     </a:rPr>
                                   </m:ctrlPr>
                                 </m:fPr>
                                 <m:num>
                                   <m:r>
-                                    <a:rPr lang="en-US" sz="3500" i="1">
+                                    <a:rPr lang="en-US" sz="3300" i="1">
                                       <a:latin typeface="Cambria Math"/>
                                     </a:rPr>
                                     <m:t>𝜀</m:t>
@@ -5505,13 +5533,13 @@
                                 </m:num>
                                 <m:den>
                                   <m:r>
-                                    <a:rPr lang="en-US" sz="3500" i="1">
+                                    <a:rPr lang="en-US" sz="3300" i="1">
                                       <a:latin typeface="Cambria Math"/>
                                     </a:rPr>
                                     <m:t>1−</m:t>
                                   </m:r>
                                   <m:r>
-                                    <a:rPr lang="en-US" sz="3500" i="1">
+                                    <a:rPr lang="en-US" sz="3300" i="1">
                                       <a:latin typeface="Cambria Math"/>
                                     </a:rPr>
                                     <m:t>𝜀</m:t>
@@ -5521,7 +5549,7 @@
                               <m:f>
                                 <m:fPr>
                                   <m:ctrlPr>
-                                    <a:rPr lang="en-US" sz="3500" i="1">
+                                    <a:rPr lang="en-US" sz="3300" i="1">
                                       <a:latin typeface="Cambria Math" panose="02040503050406030204" pitchFamily="18" charset="0"/>
                                     </a:rPr>
                                   </m:ctrlPr>
@@ -5530,14 +5558,14 @@
                                   <m:sSub>
                                     <m:sSubPr>
                                       <m:ctrlPr>
-                                        <a:rPr lang="en-US" sz="3500" i="1">
+                                        <a:rPr lang="en-US" sz="3300" i="1">
                                           <a:latin typeface="Cambria Math"/>
                                         </a:rPr>
                                       </m:ctrlPr>
                                     </m:sSubPr>
                                     <m:e>
                                       <m:r>
-                                        <a:rPr lang="en-US" sz="3500" i="1">
+                                        <a:rPr lang="en-US" sz="3300" i="1">
                                           <a:latin typeface="Cambria Math"/>
                                         </a:rPr>
                                         <m:t>𝑡</m:t>
@@ -5548,7 +5576,7 @@
                                         <m:rPr>
                                           <m:sty m:val="p"/>
                                         </m:rPr>
-                                        <a:rPr lang="en-US" sz="3500" i="0">
+                                        <a:rPr lang="en-US" sz="3300" i="0">
                                           <a:latin typeface="Cambria Math"/>
                                         </a:rPr>
                                         <m:t>Edd</m:t>
@@ -5558,13 +5586,13 @@
                                 </m:num>
                                 <m:den>
                                   <m:r>
-                                    <a:rPr lang="en-US" sz="3500" i="1">
+                                    <a:rPr lang="en-US" sz="3300" i="1">
                                       <a:latin typeface="Cambria Math"/>
                                     </a:rPr>
                                     <m:t>𝛥</m:t>
                                   </m:r>
                                   <m:r>
-                                    <a:rPr lang="en-US" sz="3500" i="1">
+                                    <a:rPr lang="en-US" sz="3300" i="1">
                                       <a:latin typeface="Cambria Math"/>
                                     </a:rPr>
                                     <m:t>𝑡</m:t>
@@ -5574,7 +5602,7 @@
                               <m:func>
                                 <m:funcPr>
                                   <m:ctrlPr>
-                                    <a:rPr lang="en-US" sz="3500" i="0">
+                                    <a:rPr lang="en-US" sz="3300" i="0">
                                       <a:latin typeface="Cambria Math"/>
                                     </a:rPr>
                                   </m:ctrlPr>
@@ -5584,7 +5612,7 @@
                                     <m:rPr>
                                       <m:sty m:val="p"/>
                                     </m:rPr>
-                                    <a:rPr lang="en-US" sz="3500" i="0">
+                                    <a:rPr lang="en-US" sz="3300" i="0">
                                       <a:latin typeface="Cambria Math"/>
                                     </a:rPr>
                                     <m:t>ln</m:t>
@@ -5594,7 +5622,7 @@
                                   <m:d>
                                     <m:dPr>
                                       <m:ctrlPr>
-                                        <a:rPr lang="en-US" sz="3500" i="1">
+                                        <a:rPr lang="en-US" sz="3300" i="1">
                                           <a:latin typeface="Cambria Math" panose="02040503050406030204" pitchFamily="18" charset="0"/>
                                         </a:rPr>
                                       </m:ctrlPr>
@@ -5603,7 +5631,7 @@
                                       <m:f>
                                         <m:fPr>
                                           <m:ctrlPr>
-                                            <a:rPr lang="en-US" sz="3500" i="1">
+                                            <a:rPr lang="en-US" sz="3300" i="1">
                                               <a:latin typeface="Cambria Math" panose="02040503050406030204" pitchFamily="18" charset="0"/>
                                             </a:rPr>
                                           </m:ctrlPr>
@@ -5612,14 +5640,14 @@
                                           <m:sSub>
                                             <m:sSubPr>
                                               <m:ctrlPr>
-                                                <a:rPr lang="en-US" sz="3500" i="1">
+                                                <a:rPr lang="en-US" sz="3300" i="1">
                                                   <a:latin typeface="Cambria Math"/>
                                                 </a:rPr>
                                               </m:ctrlPr>
                                             </m:sSubPr>
                                             <m:e>
                                               <m:r>
-                                                <a:rPr lang="en-US" sz="3500" i="1">
+                                                <a:rPr lang="en-US" sz="3300" i="1">
                                                   <a:latin typeface="Cambria Math"/>
                                                 </a:rPr>
                                                 <m:t>𝑀</m:t>
@@ -5630,7 +5658,7 @@
                                                 <m:rPr>
                                                   <m:sty m:val="p"/>
                                                 </m:rPr>
-                                                <a:rPr lang="en-US" sz="3500" i="0">
+                                                <a:rPr lang="en-US" sz="3300" i="0">
                                                   <a:latin typeface="Cambria Math"/>
                                                 </a:rPr>
                                                 <m:t>BH</m:t>
@@ -5642,14 +5670,14 @@
                                           <m:sSub>
                                             <m:sSubPr>
                                               <m:ctrlPr>
-                                                <a:rPr lang="en-US" sz="3500" i="1">
+                                                <a:rPr lang="en-US" sz="3300" i="1">
                                                   <a:latin typeface="Cambria Math"/>
                                                 </a:rPr>
                                               </m:ctrlPr>
                                             </m:sSubPr>
                                             <m:e>
                                               <m:r>
-                                                <a:rPr lang="en-US" sz="3500" i="1">
+                                                <a:rPr lang="en-US" sz="3300" i="1">
                                                   <a:latin typeface="Cambria Math"/>
                                                 </a:rPr>
                                                 <m:t>𝐵</m:t>
@@ -5660,7 +5688,7 @@
                                                 <m:rPr>
                                                   <m:sty m:val="p"/>
                                                 </m:rPr>
-                                                <a:rPr lang="en-US" sz="3500" i="0">
+                                                <a:rPr lang="en-US" sz="3300" i="0">
                                                   <a:latin typeface="Cambria Math"/>
                                                 </a:rPr>
                                                 <m:t>merge</m:t>
@@ -5670,14 +5698,14 @@
                                           <m:sSub>
                                             <m:sSubPr>
                                               <m:ctrlPr>
-                                                <a:rPr lang="en-US" sz="3500" i="1">
+                                                <a:rPr lang="en-US" sz="3300" i="1">
                                                   <a:latin typeface="Cambria Math"/>
                                                 </a:rPr>
                                               </m:ctrlPr>
                                             </m:sSubPr>
                                             <m:e>
                                               <m:r>
-                                                <a:rPr lang="en-US" sz="3500" i="1">
+                                                <a:rPr lang="en-US" sz="3300" i="1">
                                                   <a:latin typeface="Cambria Math"/>
                                                 </a:rPr>
                                                 <m:t>𝑀</m:t>
@@ -5688,7 +5716,7 @@
                                                 <m:rPr>
                                                   <m:sty m:val="p"/>
                                                 </m:rPr>
-                                                <a:rPr lang="en-US" sz="3500" i="0">
+                                                <a:rPr lang="en-US" sz="3300" i="0">
                                                   <a:latin typeface="Cambria Math"/>
                                                 </a:rPr>
                                                 <m:t>seed</m:t>
@@ -5708,7 +5736,7 @@
                     </m:oMath>
                   </m:oMathPara>
                 </a14:m>
-                <a:endParaRPr lang="en-CA" sz="3500" b="1" dirty="0">
+                <a:endParaRPr lang="en-CA" sz="3300" b="1" dirty="0">
                   <a:latin typeface="Aptos"/>
                 </a:endParaRPr>
               </a:p>
@@ -5720,67 +5748,67 @@
                   <a:buNone/>
                 </a:pPr>
                 <a:r>
-                  <a:rPr lang="en-CA" sz="3500" b="1" dirty="0">
+                  <a:rPr lang="en-CA" sz="3300" b="1" dirty="0">
                     <a:latin typeface="Aptos"/>
                   </a:rPr>
                   <a:t>Symbols: </a:t>
                 </a:r>
                 <a:r>
-                  <a:rPr lang="en-CA" sz="3500" b="0" dirty="0">
+                  <a:rPr lang="en-CA" sz="3300" b="0" dirty="0">
                     <a:latin typeface="Aptos"/>
                   </a:rPr>
                   <a:t>M⊙: solar mass; M</a:t>
                 </a:r>
                 <a:r>
-                  <a:rPr lang="en-CA" sz="2450" b="0" baseline="-25000" dirty="0">
+                  <a:rPr lang="en-CA" sz="3300" b="0" baseline="-25000" dirty="0">
                     <a:latin typeface="Aptos"/>
                   </a:rPr>
                   <a:t>BH</a:t>
                 </a:r>
                 <a:r>
-                  <a:rPr lang="en-CA" sz="3500" b="0" dirty="0">
+                  <a:rPr lang="en-CA" sz="3300" b="0" dirty="0">
                     <a:latin typeface="Aptos"/>
                   </a:rPr>
                   <a:t>: observed mass; </a:t>
                 </a:r>
                 <a:r>
-                  <a:rPr lang="en-CA" sz="3500" b="0" dirty="0" err="1">
+                  <a:rPr lang="en-CA" sz="3300" b="0" dirty="0" err="1">
                     <a:latin typeface="Aptos"/>
                   </a:rPr>
                   <a:t>M</a:t>
                 </a:r>
                 <a:r>
-                  <a:rPr lang="en-CA" sz="2450" b="0" baseline="-25000" dirty="0" err="1">
+                  <a:rPr lang="en-CA" sz="3300" b="0" baseline="-25000" dirty="0" err="1">
                     <a:latin typeface="Aptos"/>
                   </a:rPr>
                   <a:t>seed</a:t>
                 </a:r>
                 <a:r>
-                  <a:rPr lang="en-CA" sz="3500" b="0" dirty="0">
+                  <a:rPr lang="en-CA" sz="3300" b="0" dirty="0">
                     <a:latin typeface="Aptos"/>
                   </a:rPr>
                   <a:t>: seed mass; </a:t>
                 </a:r>
                 <a:r>
-                  <a:rPr lang="en-CA" sz="3500" b="0" dirty="0" err="1">
+                  <a:rPr lang="en-CA" sz="3300" b="0" dirty="0" err="1">
                     <a:latin typeface="Aptos"/>
                   </a:rPr>
                   <a:t>Δt</a:t>
                 </a:r>
                 <a:r>
-                  <a:rPr lang="en-CA" sz="3500" b="0" dirty="0">
+                  <a:rPr lang="en-CA" sz="3300" b="0" dirty="0">
                     <a:latin typeface="Aptos"/>
                   </a:rPr>
                   <a:t>: growth time; </a:t>
                 </a:r>
                 <a:r>
-                  <a:rPr lang="en-CA" sz="3500" b="0" dirty="0" err="1">
+                  <a:rPr lang="en-CA" sz="3300" b="0" dirty="0" err="1">
                     <a:latin typeface="Aptos"/>
                   </a:rPr>
                   <a:t>ε</a:t>
                 </a:r>
                 <a:r>
-                  <a:rPr lang="en-CA" sz="3500" b="0" dirty="0">
+                  <a:rPr lang="en-CA" sz="3300" b="0" dirty="0">
                     <a:latin typeface="Aptos"/>
                   </a:rPr>
                   <a:t>: radiated fraction of inflowing rest-mass energy. Larger z means earlier time.</a:t>
@@ -5794,16 +5822,47 @@
                   <a:buNone/>
                 </a:pPr>
                 <a:r>
-                  <a:rPr lang="en-CA" sz="3500" b="1" dirty="0">
+                  <a:rPr sz="3300" b="1" i="0" lang="en-CA">
                     <a:latin typeface="Aptos"/>
                   </a:rPr>
                   <a:t>Eddington ratio: </a:t>
                 </a:r>
                 <a:r>
-                  <a:rPr lang="en-CA" sz="3500" b="0" dirty="0">
+                  <a:rPr sz="3300" b="0" i="1" lang="en-CA">
                     <a:latin typeface="Aptos"/>
                   </a:rPr>
-                  <a:t>Luminosity divided by the Eddington limit. The lifetime average includes inactive periods. Values above 1 require super-Eddington episodes under this model.</a:t>
+                  <a:t>f</a:t>
+                </a:r>
+                <a:r>
+                  <a:rPr sz="2200" b="0" i="0" lang="en-CA" baseline="-25000">
+                    <a:latin typeface="Aptos"/>
+                  </a:rPr>
+                  <a:t>Edd</a:t>
+                </a:r>
+                <a:r>
+                  <a:rPr sz="3300" b="0" i="0" lang="en-CA">
+                    <a:latin typeface="Aptos"/>
+                  </a:rPr>
+                  <a:t>: luminosity/Eddington limit.</a:t>
+                </a:r>
+                <a:br/>
+                <a:r>
+                  <a:rPr sz="3300" b="0" i="1" lang="en-CA">
+                    <a:latin typeface="Aptos"/>
+                  </a:rPr>
+                  <a:t>f̄</a:t>
+                </a:r>
+                <a:r>
+                  <a:rPr sz="2200" b="0" i="0" lang="en-CA" baseline="-25000">
+                    <a:latin typeface="Aptos"/>
+                  </a:rPr>
+                  <a:t>Edd,req</a:t>
+                </a:r>
+                <a:r>
+                  <a:rPr sz="3300" b="0" i="0" lang="en-CA">
+                    <a:latin typeface="Aptos"/>
+                  </a:rPr>
+                  <a:t>: required lifetime average, including inactive periods. Values above 1 require super-Eddington episodes under this model.</a:t>
                 </a:r>
               </a:p>
               <a:p>
@@ -5814,16 +5873,16 @@
                   <a:buNone/>
                 </a:pPr>
                 <a:r>
-                  <a:rPr lang="en-CA" sz="3500" b="1" dirty="0">
+                  <a:rPr lang="en-CA" sz="3300" b="1" dirty="0">
                     <a:latin typeface="Aptos"/>
                   </a:rPr>
                   <a:t>Uncertainty: </a:t>
                 </a:r>
                 <a:r>
-                  <a:rPr lang="en-CA" sz="3500" b="0" dirty="0">
+                  <a:rPr lang="en-CA" sz="3300" b="0" dirty="0">
                     <a:latin typeface="Aptos"/>
                   </a:rPr>
-                  <a:t>10,000 draws approximate reported asymmetric log-mass errors. Twelve objects without errors enter central-mass calculations only.</a:t>
+                  <a:t>Used 10,000 draws to approximate reported asymmetric log-mass errors. Included 12 objects without errors in central-mass calculations only.</a:t>
                 </a:r>
               </a:p>
               <a:p>
@@ -5834,16 +5893,16 @@
                   <a:buNone/>
                 </a:pPr>
                 <a:r>
-                  <a:rPr lang="en-CA" sz="3500" b="1" dirty="0">
+                  <a:rPr lang="en-CA" sz="3300" b="1" dirty="0">
                     <a:latin typeface="Aptos"/>
                   </a:rPr>
                   <a:t>Sensitivity: </a:t>
                 </a:r>
                 <a:r>
-                  <a:rPr lang="en-CA" sz="3500" b="0" dirty="0">
+                  <a:rPr lang="en-CA" sz="3300" b="0" dirty="0">
                     <a:latin typeface="Aptos"/>
                   </a:rPr>
-                  <a:t>Vary mass scale, seed mass, onset, and efficiency separately. Reported errors may omit calibration scatter.</a:t>
+                  <a:t>Varied mass scale, seed mass, onset, and efficiency separately. Reported errors may omit calibration scatter.</a:t>
                 </a:r>
               </a:p>
               <a:p>
@@ -5854,40 +5913,40 @@
                   <a:buNone/>
                 </a:pPr>
                 <a:r>
-                  <a:rPr lang="en-CA" sz="3500" b="1" dirty="0">
+                  <a:rPr lang="en-CA" sz="3300" b="1" dirty="0">
                     <a:latin typeface="Aptos"/>
                   </a:rPr>
                   <a:t>Earlier onset: </a:t>
                 </a:r>
                 <a:r>
-                  <a:rPr lang="en-CA" sz="3500" b="0" dirty="0">
+                  <a:rPr lang="en-CA" sz="3300" b="0" dirty="0">
                     <a:latin typeface="Aptos"/>
                   </a:rPr>
-                  <a:t>For the three leading primary targets and GN-z11, solve minimum seed masses over 20 ≤ </a:t>
-                </a:r>
-                <a:r>
-                  <a:rPr lang="en-CA" sz="3500" b="0" dirty="0" err="1">
+                  <a:t>For the 3 leading primary targets and GN-z11, solved minimum seed masses over 20 ≤ </a:t>
+                </a:r>
+                <a:r>
+                  <a:rPr lang="en-CA" sz="3300" b="0" dirty="0" err="1">
                     <a:latin typeface="Aptos"/>
                   </a:rPr>
                   <a:t>z</a:t>
                 </a:r>
                 <a:r>
-                  <a:rPr lang="en-CA" sz="2450" b="0" baseline="-25000" dirty="0" err="1">
+                  <a:rPr lang="en-CA" sz="3300" b="0" baseline="-25000" dirty="0" err="1">
                     <a:latin typeface="Aptos"/>
                   </a:rPr>
                   <a:t>acc</a:t>
                 </a:r>
                 <a:r>
-                  <a:rPr lang="en-CA" sz="3500" b="0" dirty="0">
+                  <a:rPr lang="en-CA" sz="3300" b="0" dirty="0">
                     <a:latin typeface="Aptos"/>
                   </a:rPr>
-                  <a:t> ≤ 3400 using radiation-inclusive ages. Access to fuel is assumed.</a:t>
+                  <a:t> ≤ 3,400 using radiation-inclusive ages. Assumed access to fuel.</a:t>
                 </a:r>
               </a:p>
             </p:txBody>
           </p:sp>
         </mc:Choice>
-        <mc:Fallback xmlns="">
+        <mc:Fallback>
           <p:sp xmlns:a14="http://schemas.microsoft.com/office/drawing/2010/main">
             <p:nvSpPr>
               <p:cNvPr id="73" name="TextBox 72">
@@ -5902,8 +5961,8 @@
             </p:nvSpPr>
             <p:spPr>
               <a:xfrm>
-                <a:off x="1463040" y="11978640"/>
-                <a:ext cx="14173200" cy="12344400"/>
+                <a:off x="1463040" y="11772769"/>
+                <a:ext cx="14173200" cy="12984480"/>
               </a:xfrm>
               <a:prstGeom prst="rect">
                 <a:avLst/>
@@ -5923,16 +5982,16 @@
                   <a:buNone/>
                 </a:pPr>
                 <a:r>
-                  <a:rPr sz="3500" b="1" lang="en-CA">
+                  <a:rPr lang="en-CA" sz="3300" b="1" dirty="0">
                     <a:latin typeface="Aptos"/>
                   </a:rPr>
                   <a:t>Catalogue: </a:t>
                 </a:r>
                 <a:r>
-                  <a:rPr sz="3500" b="0" lang="en-CA">
+                  <a:rPr lang="en-CA" sz="3300" b="0" dirty="0">
                     <a:latin typeface="Aptos"/>
                   </a:rPr>
-                  <a:t>350 published measurements from 32 source families at z ≥ 4. Adopt one measurement per object and retain sources, methods, and alternatives. Primary: 220 objects with Balmer-line virial masses [1]; expanded: 234, including tentative candidates and GN-z11 [2].</a:t>
+                  <a:t>Compiled 350 published measurements from 32 source families at z ≥ 4. Adopted 1 measurement per object and retained sources, methods, and alternatives. Primary: 220 objects with Balmer-line virial masses [1]; expanded: 234, including tentative candidates and GN-z11 [2].</a:t>
                 </a:r>
               </a:p>
               <a:p>
@@ -5943,49 +6002,61 @@
                   <a:buNone/>
                 </a:pPr>
                 <a:r>
-                  <a:rPr sz="3500" b="1" lang="en-CA">
+                  <a:rPr lang="en-CA" sz="3300" b="1" dirty="0">
                     <a:latin typeface="Aptos"/>
                   </a:rPr>
                   <a:t>Reference model: </a:t>
                 </a:r>
                 <a:r>
-                  <a:rPr sz="3500" b="0" lang="en-CA">
+                  <a:rPr lang="en-CA" sz="3300" b="0" dirty="0">
                     <a:latin typeface="Aptos"/>
                   </a:rPr>
-                  <a:t>100 M⊙ seeds at z = 30, radiative efficiency ε = 0.1, no mergers (</a:t>
-                </a:r>
-                <a:r>
-                  <a:rPr sz="3500" b="0" lang="en-CA">
+                  <a:t>Assumed 100 M⊙ seeds at z = 30, radiative efficiency </a:t>
+                </a:r>
+                <a:r>
+                  <a:rPr lang="en-CA" sz="3300" b="0" dirty="0" err="1">
                     <a:latin typeface="Aptos"/>
                   </a:rPr>
+                  <a:t>ε</a:t>
+                </a:r>
+                <a:r>
+                  <a:rPr lang="en-CA" sz="3300" b="0" dirty="0">
+                    <a:latin typeface="Aptos"/>
+                  </a:rPr>
+                  <a:t> = 0.1, no mergers (</a:t>
+                </a:r>
+                <a:r>
+                  <a:rPr lang="en-CA" sz="3300" b="0" dirty="0" err="1">
+                    <a:latin typeface="Aptos"/>
+                  </a:rPr>
                   <a:t>B</a:t>
                 </a:r>
                 <a:r>
-                  <a:rPr sz="2450" b="0" lang="en-CA" baseline="-25000">
+                  <a:rPr lang="en-CA" sz="3300" b="0" baseline="-25000" dirty="0" err="1">
                     <a:latin typeface="Aptos"/>
                   </a:rPr>
                   <a:t>merge</a:t>
                 </a:r>
                 <a:r>
-                  <a:rPr sz="3500" b="0" lang="en-CA">
+                  <a:rPr lang="en-CA" sz="3300" b="0" dirty="0">
                     <a:latin typeface="Aptos"/>
                   </a:rPr>
                   <a:t> = 1), and </a:t>
                 </a:r>
                 <a:r>
-                  <a:rPr sz="3500" b="0" lang="en-CA">
+                  <a:rPr lang="en-CA" sz="3300" b="0" dirty="0" err="1">
                     <a:latin typeface="Aptos"/>
                   </a:rPr>
                   <a:t>t</a:t>
                 </a:r>
                 <a:r>
-                  <a:rPr sz="2450" b="0" lang="en-CA" baseline="-25000">
+                  <a:rPr lang="en-CA" sz="3300" b="0" baseline="-25000" dirty="0" err="1">
                     <a:latin typeface="Aptos"/>
                   </a:rPr>
                   <a:t>Edd</a:t>
                 </a:r>
                 <a:r>
-                  <a:rPr sz="3500" b="0" lang="en-CA">
+                  <a:rPr lang="en-CA" sz="3300" b="0" dirty="0">
                     <a:latin typeface="Aptos"/>
                   </a:rPr>
                   <a:t> ≈ 0.45 Gyr [3].</a:t>
@@ -5999,82 +6070,24 @@
                   <a:buNone/>
                 </a:pPr>
                 <a:r>
-                  <a:rPr sz="2600" b="0" lang="en-CA">
+                  <a:rPr sz="3300" b="1" i="0" lang="en-CA">
                     <a:latin typeface="Aptos"/>
                   </a:rPr>
-                  <a:t>f̄Edd,req = max[0, ε/(1−ε) × </a:t>
-                </a:r>
-                <a:r>
-                  <a:rPr sz="2600" b="0" lang="en-CA">
+                  <a:t>Model tests: </a:t>
+                </a:r>
+                <a:r>
+                  <a:rPr sz="3300" b="0" i="0" lang="en-CA">
                     <a:latin typeface="Aptos"/>
                   </a:rPr>
-                  <a:t>t</a:t>
-                </a:r>
-                <a:r>
-                  <a:rPr sz="1820" b="0" lang="en-CA" baseline="-25000">
-                    <a:latin typeface="Aptos"/>
-                  </a:rPr>
-                  <a:t>Edd</a:t>
-                </a:r>
-                <a:r>
-                  <a:rPr sz="2600" b="0" lang="en-CA">
-                    <a:latin typeface="Aptos"/>
-                  </a:rPr>
-                  <a:t>/Δt × ln(</a:t>
-                </a:r>
-                <a:r>
-                  <a:rPr sz="2600" b="0" lang="en-CA">
-                    <a:latin typeface="Aptos"/>
-                  </a:rPr>
-                  <a:t>M</a:t>
-                </a:r>
-                <a:r>
-                  <a:rPr sz="1820" b="0" lang="en-CA" baseline="-25000">
-                    <a:latin typeface="Aptos"/>
-                  </a:rPr>
-                  <a:t>BH</a:t>
-                </a:r>
-                <a:r>
-                  <a:rPr sz="2600" b="0" lang="en-CA">
-                    <a:latin typeface="Aptos"/>
-                  </a:rPr>
-                  <a:t>/(</a:t>
-                </a:r>
-                <a:r>
-                  <a:rPr sz="2600" b="0" lang="en-CA">
-                    <a:latin typeface="Aptos"/>
-                  </a:rPr>
-                  <a:t>B</a:t>
-                </a:r>
-                <a:r>
-                  <a:rPr sz="1820" b="0" lang="en-CA" baseline="-25000">
-                    <a:latin typeface="Aptos"/>
-                  </a:rPr>
-                  <a:t>merge</a:t>
-                </a:r>
-                <a:r>
-                  <a:rPr sz="2600" b="0" lang="en-CA">
-                    <a:latin typeface="Aptos"/>
-                  </a:rPr>
-                  <a:t> </a:t>
-                </a:r>
-                <a:r>
-                  <a:rPr sz="2600" b="0" lang="en-CA">
-                    <a:latin typeface="Aptos"/>
-                  </a:rPr>
-                  <a:t>M</a:t>
-                </a:r>
-                <a:r>
-                  <a:rPr sz="1820" b="0" lang="en-CA" baseline="-25000">
-                    <a:latin typeface="Aptos"/>
-                  </a:rPr>
-                  <a:t>seed</a:t>
-                </a:r>
-                <a:r>
-                  <a:rPr sz="2600" b="0" lang="en-CA">
-                    <a:latin typeface="Aptos"/>
-                  </a:rPr>
-                  <a:t>))]</a:t>
+                  <a:t>Calculated the average Eddington ratio required to reach each observed mass. Ranked these requirements and compared them with each model’s allowed average.</a:t>
+                </a:r>
+              </a:p>
+              <a:p>
+                <a:r>
+                  <a:rPr sz="2600">
+                    <a:latin typeface="Cambria Math"/>
+                  </a:rPr>
+                  <a:t>f̄Edd,req = max[0, ε/(1−ε) × tEdd/Δt × ln(MBH/(Bmerge Mseed))]</a:t>
                 </a:r>
               </a:p>
               <a:p>
@@ -6085,52 +6098,70 @@
                   <a:buNone/>
                 </a:pPr>
                 <a:r>
-                  <a:rPr sz="3500" b="1" lang="en-CA">
+                  <a:rPr lang="en-CA" sz="3300" b="1" dirty="0">
                     <a:latin typeface="Aptos"/>
                   </a:rPr>
                   <a:t>Symbols: </a:t>
                 </a:r>
                 <a:r>
-                  <a:rPr sz="3500" b="0" lang="en-CA">
+                  <a:rPr lang="en-CA" sz="3300" b="0" dirty="0">
                     <a:latin typeface="Aptos"/>
                   </a:rPr>
-                  <a:t>M⊙: solar mass; </a:t>
-                </a:r>
-                <a:r>
-                  <a:rPr sz="3500" b="0" lang="en-CA">
+                  <a:t>M⊙: solar mass; M</a:t>
+                </a:r>
+                <a:r>
+                  <a:rPr lang="en-CA" sz="3300" b="0" baseline="-25000" dirty="0">
                     <a:latin typeface="Aptos"/>
                   </a:rPr>
+                  <a:t>BH</a:t>
+                </a:r>
+                <a:r>
+                  <a:rPr lang="en-CA" sz="3300" b="0" dirty="0">
+                    <a:latin typeface="Aptos"/>
+                  </a:rPr>
+                  <a:t>: observed mass; </a:t>
+                </a:r>
+                <a:r>
+                  <a:rPr lang="en-CA" sz="3300" b="0" dirty="0" err="1">
+                    <a:latin typeface="Aptos"/>
+                  </a:rPr>
                   <a:t>M</a:t>
                 </a:r>
                 <a:r>
-                  <a:rPr sz="2450" b="0" lang="en-CA" baseline="-25000">
+                  <a:rPr lang="en-CA" sz="3300" b="0" baseline="-25000" dirty="0" err="1">
                     <a:latin typeface="Aptos"/>
                   </a:rPr>
-                  <a:t>BH</a:t>
-                </a:r>
-                <a:r>
-                  <a:rPr sz="3500" b="0" lang="en-CA">
+                  <a:t>seed</a:t>
+                </a:r>
+                <a:r>
+                  <a:rPr lang="en-CA" sz="3300" b="0" dirty="0">
                     <a:latin typeface="Aptos"/>
                   </a:rPr>
-                  <a:t>: observed mass; </a:t>
-                </a:r>
-                <a:r>
-                  <a:rPr sz="3500" b="0" lang="en-CA">
+                  <a:t>: seed mass; </a:t>
+                </a:r>
+                <a:r>
+                  <a:rPr lang="en-CA" sz="3300" b="0" dirty="0" err="1">
                     <a:latin typeface="Aptos"/>
                   </a:rPr>
-                  <a:t>M</a:t>
-                </a:r>
-                <a:r>
-                  <a:rPr sz="2450" b="0" lang="en-CA" baseline="-25000">
+                  <a:t>Δt</a:t>
+                </a:r>
+                <a:r>
+                  <a:rPr lang="en-CA" sz="3300" b="0" dirty="0">
                     <a:latin typeface="Aptos"/>
                   </a:rPr>
-                  <a:t>seed</a:t>
-                </a:r>
-                <a:r>
-                  <a:rPr sz="3500" b="0" lang="en-CA">
+                  <a:t>: growth time; </a:t>
+                </a:r>
+                <a:r>
+                  <a:rPr lang="en-CA" sz="3300" b="0" dirty="0" err="1">
                     <a:latin typeface="Aptos"/>
                   </a:rPr>
-                  <a:t>: seed mass; Δt: growth time; ε: radiated fraction of inflowing rest-mass energy. Larger z means earlier time.</a:t>
+                  <a:t>ε</a:t>
+                </a:r>
+                <a:r>
+                  <a:rPr lang="en-CA" sz="3300" b="0" dirty="0">
+                    <a:latin typeface="Aptos"/>
+                  </a:rPr>
+                  <a:t>: radiated fraction of inflowing rest-mass energy. Larger z means earlier time.</a:t>
                 </a:r>
               </a:p>
               <a:p>
@@ -6141,16 +6172,47 @@
                   <a:buNone/>
                 </a:pPr>
                 <a:r>
-                  <a:rPr sz="3500" b="1" lang="en-CA">
+                  <a:rPr sz="3300" b="1" i="0" lang="en-CA">
                     <a:latin typeface="Aptos"/>
                   </a:rPr>
                   <a:t>Eddington ratio: </a:t>
                 </a:r>
                 <a:r>
-                  <a:rPr sz="3500" b="0" lang="en-CA">
+                  <a:rPr sz="3300" b="0" i="1" lang="en-CA">
                     <a:latin typeface="Aptos"/>
                   </a:rPr>
-                  <a:t>Luminosity divided by the Eddington limit. The lifetime average includes inactive periods. Values above 1 require super-Eddington episodes under this model.</a:t>
+                  <a:t>f</a:t>
+                </a:r>
+                <a:r>
+                  <a:rPr sz="2200" b="0" i="0" lang="en-CA" baseline="-25000">
+                    <a:latin typeface="Aptos"/>
+                  </a:rPr>
+                  <a:t>Edd</a:t>
+                </a:r>
+                <a:r>
+                  <a:rPr sz="3300" b="0" i="0" lang="en-CA">
+                    <a:latin typeface="Aptos"/>
+                  </a:rPr>
+                  <a:t>: luminosity/Eddington limit.</a:t>
+                </a:r>
+                <a:br/>
+                <a:r>
+                  <a:rPr sz="3300" b="0" i="1" lang="en-CA">
+                    <a:latin typeface="Aptos"/>
+                  </a:rPr>
+                  <a:t>f̄</a:t>
+                </a:r>
+                <a:r>
+                  <a:rPr sz="2200" b="0" i="0" lang="en-CA" baseline="-25000">
+                    <a:latin typeface="Aptos"/>
+                  </a:rPr>
+                  <a:t>Edd,req</a:t>
+                </a:r>
+                <a:r>
+                  <a:rPr sz="3300" b="0" i="0" lang="en-CA">
+                    <a:latin typeface="Aptos"/>
+                  </a:rPr>
+                  <a:t>: required lifetime average, including inactive periods. Values above 1 require super-Eddington episodes under this model.</a:t>
                 </a:r>
               </a:p>
               <a:p>
@@ -6161,16 +6223,16 @@
                   <a:buNone/>
                 </a:pPr>
                 <a:r>
-                  <a:rPr sz="3500" b="1" lang="en-CA">
+                  <a:rPr lang="en-CA" sz="3300" b="1" dirty="0">
                     <a:latin typeface="Aptos"/>
                   </a:rPr>
                   <a:t>Uncertainty: </a:t>
                 </a:r>
                 <a:r>
-                  <a:rPr sz="3500" b="0" lang="en-CA">
+                  <a:rPr lang="en-CA" sz="3300" b="0" dirty="0">
                     <a:latin typeface="Aptos"/>
                   </a:rPr>
-                  <a:t>10,000 draws approximate reported asymmetric log-mass errors. Twelve objects without errors enter central-mass calculations only.</a:t>
+                  <a:t>Used 10,000 draws to approximate reported asymmetric log-mass errors. Included 12 objects without errors in central-mass calculations only.</a:t>
                 </a:r>
               </a:p>
               <a:p>
@@ -6181,16 +6243,16 @@
                   <a:buNone/>
                 </a:pPr>
                 <a:r>
-                  <a:rPr sz="3500" b="1" lang="en-CA">
+                  <a:rPr lang="en-CA" sz="3300" b="1" dirty="0">
                     <a:latin typeface="Aptos"/>
                   </a:rPr>
                   <a:t>Sensitivity: </a:t>
                 </a:r>
                 <a:r>
-                  <a:rPr sz="3500" b="0" lang="en-CA">
+                  <a:rPr lang="en-CA" sz="3300" b="0" dirty="0">
                     <a:latin typeface="Aptos"/>
                   </a:rPr>
-                  <a:t>Vary mass scale, seed mass, onset, and efficiency separately. Reported errors may omit calibration scatter.</a:t>
+                  <a:t>Varied mass scale, seed mass, onset, and efficiency separately. Reported errors may omit calibration scatter.</a:t>
                 </a:r>
               </a:p>
               <a:p>
@@ -6201,34 +6263,34 @@
                   <a:buNone/>
                 </a:pPr>
                 <a:r>
-                  <a:rPr sz="3500" b="1" lang="en-CA">
+                  <a:rPr lang="en-CA" sz="3300" b="1" dirty="0">
                     <a:latin typeface="Aptos"/>
                   </a:rPr>
                   <a:t>Earlier onset: </a:t>
                 </a:r>
                 <a:r>
-                  <a:rPr sz="3500" b="0" lang="en-CA">
+                  <a:rPr lang="en-CA" sz="3300" b="0" dirty="0">
                     <a:latin typeface="Aptos"/>
                   </a:rPr>
-                  <a:t>For the three leading primary targets and GN-z11, solve minimum seed masses over 20 ≤ </a:t>
-                </a:r>
-                <a:r>
-                  <a:rPr sz="3500" b="0" lang="en-CA">
+                  <a:t>For the 3 leading primary targets and GN-z11, solved minimum seed masses over 20 ≤ </a:t>
+                </a:r>
+                <a:r>
+                  <a:rPr lang="en-CA" sz="3300" b="0" dirty="0" err="1">
                     <a:latin typeface="Aptos"/>
                   </a:rPr>
                   <a:t>z</a:t>
                 </a:r>
                 <a:r>
-                  <a:rPr sz="2450" b="0" lang="en-CA" baseline="-25000">
+                  <a:rPr lang="en-CA" sz="3300" b="0" baseline="-25000" dirty="0" err="1">
                     <a:latin typeface="Aptos"/>
                   </a:rPr>
                   <a:t>acc</a:t>
                 </a:r>
                 <a:r>
-                  <a:rPr sz="3500" b="0" lang="en-CA">
+                  <a:rPr lang="en-CA" sz="3300" b="0" dirty="0">
                     <a:latin typeface="Aptos"/>
                   </a:rPr>
-                  <a:t> ≤ 3400 using radiation-inclusive ages. Access to fuel is assumed.</a:t>
+                  <a:t> ≤ 3,400 using radiation-inclusive ages. Assumed access to fuel.</a:t>
                 </a:r>
               </a:p>
             </p:txBody>
@@ -6249,8 +6311,8 @@
         </p:nvSpPr>
         <p:spPr>
           <a:xfrm>
-            <a:off x="914400" y="10770677"/>
-            <a:ext cx="15087600" cy="13643762"/>
+            <a:off x="914400" y="10408582"/>
+            <a:ext cx="15087600" cy="14586557"/>
           </a:xfrm>
           <a:prstGeom prst="rect">
             <a:avLst/>
@@ -6365,7 +6427,7 @@
         <p:spPr>
           <a:xfrm>
             <a:off x="16841982" y="36683439"/>
-            <a:ext cx="14996160" cy="6001643"/>
+            <a:ext cx="14996160" cy="6583680"/>
           </a:xfrm>
           <a:prstGeom prst="rect">
             <a:avLst/>
@@ -6385,16 +6447,28 @@
               <a:buChar char="•"/>
             </a:pPr>
             <a:r>
-              <a:rPr lang="en-CA" sz="3200" b="1">
+              <a:rPr lang="en-CA" sz="3300" b="1" dirty="0">
                 <a:latin typeface="Aptos"/>
               </a:rPr>
               <a:t>Efficiency drives the tension: </a:t>
             </a:r>
             <a:r>
-              <a:rPr lang="en-CA" sz="3200" b="0">
+              <a:rPr lang="en-CA" sz="3300" b="0" dirty="0">
                 <a:latin typeface="Aptos"/>
               </a:rPr>
-              <a:t>Some objects challenge the reference model. At ε = 0.05719, the ideal thin-disc efficiency for a non-spinning black hole, 100 M⊙ seeds at z = 30 reach all 234 central masses with an average ratio below 1.</a:t>
+              <a:t>Some objects challenge the reference model. At </a:t>
+            </a:r>
+            <a:r>
+              <a:rPr lang="en-CA" sz="3300" b="0" dirty="0" err="1">
+                <a:latin typeface="Aptos"/>
+              </a:rPr>
+              <a:t>ε</a:t>
+            </a:r>
+            <a:r>
+              <a:rPr lang="en-CA" sz="3300" b="0" dirty="0">
+                <a:latin typeface="Aptos"/>
+              </a:rPr>
+              <a:t> = 0.05719, the ideal thin-disc efficiency for a non-spinning black hole, 100 M⊙ seeds at z = 30 reach all 234 central masses with an average ratio below 1.</a:t>
             </a:r>
           </a:p>
           <a:p>
@@ -6402,13 +6476,13 @@
               <a:buChar char="•"/>
             </a:pPr>
             <a:r>
-              <a:rPr lang="en-CA" sz="3200" b="1" dirty="0">
+              <a:rPr lang="en-CA" sz="3300" b="1" dirty="0">
                 <a:latin typeface="Aptos"/>
               </a:rPr>
               <a:t>Independent mass estimates: </a:t>
             </a:r>
             <a:r>
-              <a:rPr lang="en-CA" sz="3200" b="0" dirty="0">
+              <a:rPr lang="en-CA" sz="3300" b="0" dirty="0">
                 <a:latin typeface="Aptos"/>
               </a:rPr>
               <a:t>Tests of calibration, lensing, and scattering are essential to establish which objects are most challenging.</a:t>
@@ -6419,13 +6493,13 @@
               <a:buChar char="•"/>
             </a:pPr>
             <a:r>
-              <a:rPr lang="en-CA" sz="3200" b="1" dirty="0">
+              <a:rPr lang="en-CA" sz="3300" b="1" dirty="0">
                 <a:latin typeface="Aptos"/>
               </a:rPr>
               <a:t>Catalogue contribution: </a:t>
             </a:r>
             <a:r>
-              <a:rPr lang="en-CA" sz="3200" b="0" dirty="0">
+              <a:rPr lang="en-CA" sz="3300" b="0" dirty="0">
                 <a:latin typeface="Aptos"/>
               </a:rPr>
               <a:t>Documented measurement choices and retained alternatives support consistent comparisons and follow-up. Sample counts describe the literature sample, not population fractions.</a:t>
@@ -6436,28 +6510,28 @@
               <a:buChar char="•"/>
             </a:pPr>
             <a:r>
-              <a:rPr lang="en-CA" sz="3200" b="1" dirty="0">
+              <a:rPr lang="en-CA" sz="3300" b="1" dirty="0">
                 <a:latin typeface="Aptos"/>
               </a:rPr>
               <a:t>Earlier onset offers limited relief: </a:t>
             </a:r>
             <a:r>
-              <a:rPr lang="en-CA" sz="3200" b="0" dirty="0">
+              <a:rPr lang="en-CA" sz="3300" b="0" dirty="0">
                 <a:latin typeface="Aptos"/>
               </a:rPr>
-              <a:t>Earlier onset alone cannot rescue 100 M⊙ seeds for the four targets at </a:t>
-            </a:r>
-            <a:r>
-              <a:rPr lang="en-CA" sz="3200" b="0" dirty="0" err="1">
+              <a:t>Earlier onset alone cannot rescue 100 M⊙ seeds for the 4 targets at </a:t>
+            </a:r>
+            <a:r>
+              <a:rPr lang="en-CA" sz="3300" b="0" dirty="0" err="1">
                 <a:latin typeface="Aptos"/>
               </a:rPr>
               <a:t>ε</a:t>
             </a:r>
             <a:r>
-              <a:rPr lang="en-CA" sz="3200" b="0" dirty="0">
+              <a:rPr lang="en-CA" sz="3300" b="0" dirty="0">
                 <a:latin typeface="Aptos"/>
               </a:rPr>
-              <a:t> = 0.1, average ratio ≤1, and no mergers. Gains diminish at earlier onset. Growth compatibility does not establish primordial black hole (PBH) formation or abundance viability.</a:t>
+              <a:t> = 0.1, average ratio ≤ 1, and no mergers. Gains diminish at earlier onset. Growth compatibility does not establish primordial black hole (PBH) formation or abundance viability.</a:t>
             </a:r>
           </a:p>
         </p:txBody>
@@ -6477,7 +6551,7 @@
         <p:spPr>
           <a:xfrm>
             <a:off x="16550640" y="35503691"/>
-            <a:ext cx="15453360" cy="7349366"/>
+            <a:ext cx="15453360" cy="7930309"/>
           </a:xfrm>
           <a:prstGeom prst="rect">
             <a:avLst/>
@@ -6592,7 +6666,7 @@
         <p:spPr>
           <a:xfrm>
             <a:off x="1371600" y="39363981"/>
-            <a:ext cx="13898880" cy="3303468"/>
+            <a:ext cx="13898880" cy="3395801"/>
           </a:xfrm>
           <a:prstGeom prst="rect">
             <a:avLst/>
@@ -6611,31 +6685,31 @@
               </a:spcBef>
             </a:pPr>
             <a:r>
-              <a:rPr lang="en-CA" sz="3200" dirty="0"/>
+              <a:rPr lang="en-CA" sz="3300" dirty="0"/>
               <a:t>[1] Shen (2013), BASI, 41, 61.</a:t>
             </a:r>
-            <a:endParaRPr lang="en-US" sz="3200" dirty="0"/>
-          </a:p>
-          <a:p>
-            <a:r>
-              <a:rPr lang="en-CA" sz="3200" dirty="0"/>
+            <a:endParaRPr lang="en-US" sz="3300" dirty="0"/>
+          </a:p>
+          <a:p>
+            <a:r>
+              <a:rPr lang="en-CA" sz="3300" dirty="0"/>
               <a:t>[2] </a:t>
             </a:r>
             <a:r>
-              <a:rPr lang="en-CA" sz="3200" dirty="0" err="1"/>
+              <a:rPr lang="en-CA" sz="3300" dirty="0" err="1"/>
               <a:t>Maiolino</a:t>
             </a:r>
             <a:r>
-              <a:rPr lang="en-CA" sz="3200" dirty="0"/>
+              <a:rPr lang="en-CA" sz="3300" dirty="0"/>
               <a:t> et al. (2024), Nature, 627, 59.</a:t>
             </a:r>
           </a:p>
           <a:p>
             <a:r>
-              <a:rPr lang="en-CA" sz="3200" dirty="0"/>
+              <a:rPr lang="en-CA" sz="3300" dirty="0"/>
               <a:t>[3] Dayal (2024), A&amp;A, 690, A182.</a:t>
             </a:r>
-            <a:endParaRPr lang="en-US" sz="3200" dirty="0"/>
+            <a:endParaRPr lang="en-US" sz="3300" dirty="0"/>
           </a:p>
           <a:p>
             <a:pPr>
@@ -6644,18 +6718,18 @@
               </a:spcBef>
             </a:pPr>
             <a:r>
-              <a:rPr lang="en-CA" sz="3200" dirty="0"/>
+              <a:rPr lang="en-CA" sz="3300" dirty="0"/>
               <a:t>[4] Bardeen et al. (1972), </a:t>
             </a:r>
             <a:r>
-              <a:rPr lang="en-CA" sz="3200" dirty="0" err="1"/>
+              <a:rPr lang="en-CA" sz="3300" dirty="0" err="1"/>
               <a:t>ApJ</a:t>
             </a:r>
             <a:r>
-              <a:rPr lang="en-CA" sz="3200" dirty="0"/>
+              <a:rPr lang="en-CA" sz="3300" dirty="0"/>
               <a:t>, 178, 347.</a:t>
             </a:r>
-            <a:endParaRPr lang="en-US" sz="3200" dirty="0"/>
+            <a:endParaRPr lang="en-US" sz="3300" dirty="0"/>
           </a:p>
           <a:p>
             <a:pPr>
@@ -6665,19 +6739,19 @@
               <a:buNone/>
             </a:pPr>
             <a:r>
-              <a:rPr lang="en-CA" sz="3200" b="0" dirty="0">
+              <a:rPr lang="en-CA" sz="3300" b="0" dirty="0">
                 <a:latin typeface="Aptos"/>
               </a:rPr>
               <a:t>[5] </a:t>
             </a:r>
             <a:r>
-              <a:rPr lang="en-CA" sz="3200" b="0" dirty="0" err="1">
+              <a:rPr lang="en-CA" sz="3300" b="0" dirty="0" err="1">
                 <a:latin typeface="Aptos"/>
               </a:rPr>
               <a:t>Juodzbalis</a:t>
             </a:r>
             <a:r>
-              <a:rPr lang="en-CA" sz="3200" b="0" dirty="0">
+              <a:rPr lang="en-CA" sz="3300" b="0" dirty="0">
                 <a:latin typeface="Aptos"/>
               </a:rPr>
               <a:t> et al. (2025), arXiv:2508.21748.</a:t>
@@ -6690,10 +6764,10 @@
               </a:spcBef>
             </a:pPr>
             <a:r>
-              <a:rPr lang="en-CA" sz="3200" dirty="0"/>
+              <a:rPr lang="en-CA" sz="3300" dirty="0"/>
               <a:t>Catalogue sources and code: QR link above.</a:t>
             </a:r>
-            <a:endParaRPr lang="en-US" sz="3200" dirty="0"/>
+            <a:endParaRPr lang="en-US" sz="3300" dirty="0"/>
           </a:p>
         </p:txBody>
       </p:sp>
@@ -6712,7 +6786,7 @@
         <p:spPr>
           <a:xfrm>
             <a:off x="914400" y="38218254"/>
-            <a:ext cx="15087600" cy="4634802"/>
+            <a:ext cx="15087600" cy="5215746"/>
           </a:xfrm>
           <a:prstGeom prst="rect">
             <a:avLst/>
@@ -6764,15 +6838,15 @@
           <p:nvPr/>
         </p:nvPicPr>
         <p:blipFill>
-          <a:blip r:embed="rId8"/>
+          <a:blip r:embed="rId9"/>
           <a:stretch>
             <a:fillRect/>
           </a:stretch>
         </p:blipFill>
         <p:spPr>
           <a:xfrm>
-            <a:off x="16962120" y="11704320"/>
-            <a:ext cx="14630400" cy="8412480"/>
+            <a:off x="16962120" y="12298680"/>
+            <a:ext cx="14630400" cy="7863840"/>
           </a:xfrm>
           <a:prstGeom prst="rect">
             <a:avLst/>
@@ -6794,7 +6868,7 @@
           <p:nvPr/>
         </p:nvPicPr>
         <p:blipFill>
-          <a:blip r:embed="rId9"/>
+          <a:blip r:embed="rId10"/>
           <a:stretch>
             <a:fillRect/>
           </a:stretch>
@@ -6824,7 +6898,7 @@
           <p:nvPr/>
         </p:nvPicPr>
         <p:blipFill>
-          <a:blip r:embed="rId10"/>
+          <a:blip r:embed="rId11"/>
           <a:stretch>
             <a:fillRect/>
           </a:stretch>
@@ -6854,7 +6928,7 @@
           <p:nvPr/>
         </p:nvPicPr>
         <p:blipFill>
-          <a:blip r:embed="rId11"/>
+          <a:blip r:embed="rId12"/>
           <a:stretch>
             <a:fillRect/>
           </a:stretch>
@@ -6884,7 +6958,7 @@
         <p:spPr>
           <a:xfrm>
             <a:off x="17133324" y="21259800"/>
-            <a:ext cx="14630400" cy="1783080"/>
+            <a:ext cx="14630400" cy="1615827"/>
           </a:xfrm>
           <a:prstGeom prst="rect">
             <a:avLst/>
@@ -6905,31 +6979,31 @@
               <a:buChar char="•"/>
             </a:pPr>
             <a:r>
-              <a:rPr lang="en-CA" sz="3200" b="1" dirty="0">
+              <a:rPr lang="en-CA" sz="3300" b="1" dirty="0">
                 <a:latin typeface="Aptos"/>
               </a:rPr>
               <a:t>Earlier-onset test: </a:t>
             </a:r>
             <a:r>
-              <a:rPr lang="en-CA" sz="3200" b="0" dirty="0">
+              <a:rPr lang="en-CA" sz="3300" b="0" dirty="0">
                 <a:latin typeface="Aptos"/>
               </a:rPr>
-              <a:t>At matter–radiation equality (z = 3400), the three leading primary targets plus GN-z11 require minimum seed masses of 270–1,200 M⊙ (</a:t>
-            </a:r>
-            <a:r>
-              <a:rPr lang="en-CA" sz="3200" b="0" dirty="0" err="1">
+              <a:t>At matter–radiation equality (z = 3,400), the 3 leading primary targets plus GN-z11 require minimum seed masses of 270–1,200 M⊙ (</a:t>
+            </a:r>
+            <a:r>
+              <a:rPr lang="en-CA" sz="3300" b="0" dirty="0" err="1">
                 <a:latin typeface="Aptos"/>
               </a:rPr>
               <a:t>ε</a:t>
             </a:r>
             <a:r>
-              <a:rPr lang="en-CA" sz="3200" b="0" dirty="0">
+              <a:rPr lang="en-CA" sz="3300" b="0" dirty="0">
                 <a:latin typeface="Aptos"/>
               </a:rPr>
-              <a:t> = 0.1, average ratio ≤1, no mergers).</a:t>
-            </a:r>
-            <a:r>
-              <a:rPr lang="en-CA" sz="3200" dirty="0"/>
+              <a:t> = 0.1, average ratio ≤ 1, no mergers).</a:t>
+            </a:r>
+            <a:r>
+              <a:rPr lang="en-CA" sz="3300" dirty="0"/>
               <a:t> </a:t>
             </a:r>
           </a:p>
@@ -6949,8 +7023,8 @@
         </p:nvSpPr>
         <p:spPr>
           <a:xfrm>
-            <a:off x="17133324" y="6642638"/>
-            <a:ext cx="14413476" cy="5016758"/>
+            <a:off x="17007840" y="6642638"/>
+            <a:ext cx="14767560" cy="5170646"/>
           </a:xfrm>
           <a:prstGeom prst="rect">
             <a:avLst/>
@@ -6970,16 +7044,16 @@
               <a:buChar char="•"/>
             </a:pPr>
             <a:r>
-              <a:rPr lang="en-CA" sz="3200" b="1" dirty="0">
+              <a:rPr lang="en-CA" sz="3300" b="1" dirty="0">
                 <a:latin typeface="Aptos"/>
               </a:rPr>
               <a:t>Reference: </a:t>
             </a:r>
             <a:r>
-              <a:rPr lang="en-CA" sz="3200" b="0" dirty="0">
+              <a:rPr lang="en-CA" sz="3300" b="0" dirty="0">
                 <a:latin typeface="Aptos"/>
               </a:rPr>
-              <a:t>8/220 primary objects require an average ratio above 1; five do so in ≥95% of reported-mass-error draws.</a:t>
+              <a:t>8/220 primary objects require an average ratio above 1; 5 do so in     ≥ 95% of reported-mass-error draws.</a:t>
             </a:r>
           </a:p>
           <a:p>
@@ -6987,25 +7061,25 @@
               <a:buChar char="•"/>
             </a:pPr>
             <a:r>
-              <a:rPr lang="en-CA" sz="3200" b="1" dirty="0">
+              <a:rPr lang="en-CA" sz="3300" b="1" dirty="0">
                 <a:latin typeface="Aptos"/>
               </a:rPr>
               <a:t>Mass sensitivity: </a:t>
             </a:r>
             <a:r>
-              <a:rPr lang="en-CA" sz="3200" b="0" dirty="0">
+              <a:rPr lang="en-CA" sz="3300" b="0" dirty="0">
                 <a:latin typeface="Aptos"/>
               </a:rPr>
-              <a:t>UNCOVER-20466, COSMOS3D-13852, and RUBIES-EGS-55604 retain ≥95% support after a 0.5 </a:t>
-            </a:r>
-            <a:r>
-              <a:rPr lang="en-CA" sz="3200" b="0" dirty="0" err="1">
+              <a:t>UNCOVER-20466, COSMOS3D-13852, and RUBIES-EGS-55604 retain ≥ 95% support after a 0.5 </a:t>
+            </a:r>
+            <a:r>
+              <a:rPr lang="en-CA" sz="3300" b="0" dirty="0" err="1">
                 <a:latin typeface="Aptos"/>
               </a:rPr>
               <a:t>dex</a:t>
             </a:r>
             <a:r>
-              <a:rPr lang="en-CA" sz="3200" b="0" dirty="0">
+              <a:rPr lang="en-CA" sz="3300" b="0" dirty="0">
                 <a:latin typeface="Aptos"/>
               </a:rPr>
               <a:t> mass reduction (a factor of 3.2).</a:t>
@@ -7016,16 +7090,16 @@
               <a:buChar char="•"/>
             </a:pPr>
             <a:r>
-              <a:rPr lang="en-CA" sz="3200" b="1" dirty="0">
+              <a:rPr lang="en-CA" sz="3300" b="1" dirty="0">
                 <a:latin typeface="Aptos"/>
               </a:rPr>
               <a:t>Seed mass: </a:t>
             </a:r>
             <a:r>
-              <a:rPr lang="en-CA" sz="3200" b="0" dirty="0">
+              <a:rPr lang="en-CA" sz="3300" b="0" dirty="0">
                 <a:latin typeface="Aptos"/>
               </a:rPr>
-              <a:t>1,000 M⊙ seeds leave 3/220 above unity; 100,000 M⊙ seeds leave none in either sample.</a:t>
+              <a:t>1,000 M⊙ seeds leave 3/220 above 1; 100,000 M⊙ seeds leave 0 above 1 in either sample.</a:t>
             </a:r>
           </a:p>
           <a:p>
@@ -7033,16 +7107,16 @@
               <a:buChar char="•"/>
             </a:pPr>
             <a:r>
-              <a:rPr lang="en-CA" sz="3200" b="1" dirty="0">
+              <a:rPr lang="en-CA" sz="3300" b="1" dirty="0">
                 <a:latin typeface="Aptos"/>
               </a:rPr>
               <a:t>Formation time: </a:t>
             </a:r>
             <a:r>
-              <a:rPr lang="en-CA" sz="3200" b="0" dirty="0">
+              <a:rPr lang="en-CA" sz="3300" b="0" dirty="0">
                 <a:latin typeface="Aptos"/>
               </a:rPr>
-              <a:t>Later seeding (z = 20) gives 18/220 primary objects above unity; GN-z11 has the highest requirement in the expanded sample.</a:t>
+              <a:t>Later seeding (z = 20) gives 18/220 primary objects above 1; GN-z11 has the highest requirement in the expanded sample.</a:t>
             </a:r>
           </a:p>
           <a:p>
@@ -7050,25 +7124,25 @@
               <a:buChar char="•"/>
             </a:pPr>
             <a:r>
-              <a:rPr lang="en-CA" sz="3200" b="1" dirty="0">
+              <a:rPr lang="en-CA" sz="3300" b="1" dirty="0">
                 <a:latin typeface="Aptos"/>
               </a:rPr>
               <a:t>Efficiency: </a:t>
             </a:r>
             <a:r>
-              <a:rPr lang="en-CA" sz="3200" b="0" dirty="0">
+              <a:rPr lang="en-CA" sz="3300" b="0" dirty="0">
                 <a:latin typeface="Aptos"/>
               </a:rPr>
               <a:t>At </a:t>
             </a:r>
             <a:r>
-              <a:rPr lang="en-CA" sz="3200" b="0" dirty="0" err="1">
+              <a:rPr lang="en-CA" sz="3300" b="0" dirty="0" err="1">
                 <a:latin typeface="Aptos"/>
               </a:rPr>
               <a:t>ε</a:t>
             </a:r>
             <a:r>
-              <a:rPr lang="en-CA" sz="3200" b="0" dirty="0">
+              <a:rPr lang="en-CA" sz="3300" b="0" dirty="0">
                 <a:latin typeface="Aptos"/>
               </a:rPr>
               <a:t> = 0.05719 (non-spinning thin disc) [4], all 234 central masses are reachable from 100 M⊙ seeds at z = 30 with an average ratio below 1.</a:t>
@@ -7221,10 +7295,22 @@
               <a:buNone/>
             </a:pPr>
             <a:r>
-              <a:rPr lang="en-CA" sz="2400" b="0">
+              <a:rPr lang="en-CA" sz="2400" b="0" dirty="0">
                 <a:latin typeface="Aptos"/>
               </a:rPr>
-              <a:t>Three targets retain ≥95% reported-error support for a required average ratio above unity after a −0.5 dex mass shift.</a:t>
+              <a:t>After a −0.5 </a:t>
+            </a:r>
+            <a:r>
+              <a:rPr lang="en-CA" sz="2400" b="0" dirty="0" err="1">
+                <a:latin typeface="Aptos"/>
+              </a:rPr>
+              <a:t>dex</a:t>
+            </a:r>
+            <a:r>
+              <a:rPr lang="en-CA" sz="2400" b="0" dirty="0">
+                <a:latin typeface="Aptos"/>
+              </a:rPr>
+              <a:t> mass shift, 3 targets retain ≥ 95% reported-error support for a required average ratio above 1.</a:t>
             </a:r>
           </a:p>
         </p:txBody>
@@ -7237,7 +7323,7 @@
         </p:nvSpPr>
         <p:spPr>
           <a:xfrm>
-            <a:off x="1188720" y="36301680"/>
+            <a:off x="1188720" y="36859926"/>
             <a:ext cx="14356080" cy="1051560"/>
           </a:xfrm>
           <a:prstGeom prst="rect">
@@ -7258,7 +7344,7 @@
               <a:buNone/>
             </a:pPr>
             <a:r>
-              <a:rPr lang="en-CA" sz="2400" b="0">
+              <a:rPr lang="en-CA" sz="2400" b="0" dirty="0">
                 <a:latin typeface="Aptos"/>
               </a:rPr>
               <a:t>Only efficiency changes between panels. Points below a curve can be reached with a lower average Eddington ratio.</a:t>
@@ -7315,7 +7401,7 @@
         <p:spPr>
           <a:xfrm>
             <a:off x="17133324" y="33686452"/>
-            <a:ext cx="14413476" cy="1077218"/>
+            <a:ext cx="14413476" cy="1107996"/>
           </a:xfrm>
           <a:prstGeom prst="rect">
             <a:avLst/>
@@ -7336,18 +7422,18 @@
               <a:buChar char="•"/>
             </a:pPr>
             <a:r>
-              <a:rPr lang="en-CA" sz="3200" b="1" dirty="0">
+              <a:rPr lang="en-CA" sz="3300" b="1" dirty="0">
                 <a:latin typeface="Aptos"/>
               </a:rPr>
               <a:t>Independent mass check: </a:t>
             </a:r>
             <a:r>
-              <a:rPr lang="en-CA" sz="3200" b="0" dirty="0">
+              <a:rPr lang="en-CA" sz="3300" b="0" dirty="0">
                 <a:latin typeface="Aptos"/>
               </a:rPr>
-              <a:t>A2744-QSO1’s dynamical mass raises its required ratio from 0.929 to ≈1; uncertainty spans unity [5].</a:t>
-            </a:r>
-            <a:endParaRPr lang="en-CA" sz="3200" dirty="0"/>
+              <a:t>A2744-QSO1’s dynamical mass raises the ratio from 0.929 to ≈ 1; uncertainty spans 1 [5].</a:t>
+            </a:r>
+            <a:endParaRPr lang="en-CA" sz="3300" dirty="0"/>
           </a:p>
         </p:txBody>
       </p:sp>
@@ -7367,7 +7453,7 @@
         </p:nvSpPr>
         <p:spPr>
           <a:xfrm>
-            <a:off x="1280160" y="24825960"/>
+            <a:off x="1280160" y="25453836"/>
             <a:ext cx="14356080" cy="640080"/>
           </a:xfrm>
           <a:prstGeom prst="rect">
@@ -7401,7 +7487,7 @@
               </a:defRPr>
             </a:pPr>
             <a:r>
-              <a:rPr sz="3600" b="1">
+              <a:rPr sz="3600" b="1" dirty="0">
                 <a:solidFill>
                   <a:srgbClr val="002A5C"/>
                 </a:solidFill>

</xml_diff>